<commit_message>
fix: slide corrections per feedback
- Eyebrow: 'eScience Institute, University of Washington' restored
- Remove missed em dash in problem card (JSON files description)
- 'May to present' -> 'May 2026 onwards'
- Historical data card: clarify 'full historical data (80-90 days)'
- Regenerated PDF

Co-Authored-By: Claude Sonnet 4.6 <noreply@anthropic.com>
</commit_message>
<xml_diff>
--- a/slides/LLMoxie_Pipeline.pptx
+++ b/slides/LLMoxie_Pipeline.pptx
@@ -1917,7 +1917,7 @@
                 <a:ea typeface="Calibri" pitchFamily="34" charset="-122"/>
                 <a:cs typeface="Calibri" pitchFamily="34" charset="-120"/>
               </a:rPr>
-              <a:t>University of Washington</a:t>
+              <a:t>eScience Institute, University of Washington</a:t>
             </a:r>
             <a:endParaRPr lang="en-US" sz="1100" dirty="0"/>
           </a:p>
@@ -2362,7 +2362,7 @@
                 <a:ea typeface="Calibri" pitchFamily="34" charset="-122"/>
                 <a:cs typeface="Calibri" pitchFamily="34" charset="-120"/>
               </a:rPr>
-              <a:t>Thousands of individual JSON files — no sessions, no easy querying, no aggregation.</a:t>
+              <a:t>Thousands of individual JSON files with no sessions, no easy querying, no aggregation.</a:t>
             </a:r>
             <a:endParaRPr lang="en-US" sz="1200" dirty="0"/>
           </a:p>
@@ -4316,7 +4316,7 @@
                 <a:ea typeface="Calibri" pitchFamily="34" charset="-122"/>
                 <a:cs typeface="Calibri" pitchFamily="34" charset="-120"/>
               </a:rPr>
-              <a:t>May to present</a:t>
+              <a:t>May 2026 onwards</a:t>
             </a:r>
             <a:endParaRPr lang="en-US" sz="1100" dirty="0"/>
           </a:p>
@@ -7037,7 +7037,7 @@
                 <a:ea typeface="Calibri" pitchFamily="34" charset="-122"/>
                 <a:cs typeface="Calibri" pitchFamily="34" charset="-120"/>
               </a:rPr>
-              <a:t>Full 80-90 day data dump incoming; dashboard will show the complete picture</a:t>
+              <a:t>Full historical data (80-90 days) being loaded; dashboard will show the complete picture</a:t>
             </a:r>
             <a:endParaRPr lang="en-US" sz="1150" dirty="0"/>
           </a:p>

</xml_diff>

<commit_message>
fix: 8-day dump on architecture slide, remove from next steps
Co-Authored-By: Claude Sonnet 4.6 <noreply@anthropic.com>
</commit_message>
<xml_diff>
--- a/slides/LLMoxie_Pipeline.pptx
+++ b/slides/LLMoxie_Pipeline.pptx
@@ -4316,7 +4316,7 @@
                 <a:ea typeface="Calibri" pitchFamily="34" charset="-122"/>
                 <a:cs typeface="Calibri" pitchFamily="34" charset="-120"/>
               </a:rPr>
-              <a:t>May 2026 onwards</a:t>
+              <a:t>8-day dump</a:t>
             </a:r>
             <a:endParaRPr lang="en-US" sz="1100" dirty="0"/>
           </a:p>
@@ -7037,7 +7037,7 @@
                 <a:ea typeface="Calibri" pitchFamily="34" charset="-122"/>
                 <a:cs typeface="Calibri" pitchFamily="34" charset="-120"/>
               </a:rPr>
-              <a:t>Full historical data (8-day dump) being loaded; dashboard will show the complete picture</a:t>
+              <a:t>Full historical data being loaded; dashboard will show the complete picture</a:t>
             </a:r>
             <a:endParaRPr lang="en-US" sz="1150" dirty="0"/>
           </a:p>

</xml_diff>